<commit_message>
Make the tool report-only: build reports from customer CSV/JSON inventory exports
Remove live Azure collection (Resource Graph SDK, collect/run commands, azure extras).
Add CSV input next to JSON: Resource Graph Explorer CSV, portal 'All resources' export
(friendly type names mapped to ARM types), flattened tags./properties. columns,
comma/semicolon/tab delimiters. Several input files are merged and de-duplicated.

Checks whose data is missing from the input are reported under 'Data coverage &
limitations' instead of counting as passes; pillars without data show 'Not assessed'
and the overall score states how many pillars it covers.

Add customer-side export scripts (Azure CLI and PowerShell), a 'template' command
and an example inventory CSV.

Co-Authored-By: Claude Opus 5.5 <noreply@anthropic.com>
Claude-Session: https://claude.ai/code/session_01A3HbwoCp6EKz1YzLWTo4jQ
</commit_message>
<xml_diff>
--- a/azure-assessment/sample-reports/contoso-azure-assessment.pptx
+++ b/azure-assessment/sample-reports/contoso-azure-assessment.pptx
@@ -6399,7 +6399,7 @@
                 </a:solidFill>
                 <a:latin typeface="Calibri"/>
               </a:rPr>
-              <a:t>•  106 findings were raised: 17 high, 73 medium and 16 low severity, affecting 78 resources.</a:t>
+              <a:t>•  106 finding(s) were raised: 17 high, 73 medium and 16 low severity, affecting 78 resources.</a:t>
             </a:r>
           </a:p>
           <a:p>
@@ -6649,7 +6649,7 @@
                 </a:solidFill>
                 <a:latin typeface="Calibri"/>
               </a:rPr>
-              <a:t>•  Read-only collection via Azure Resource Graph</a:t>
+              <a:t>•  Based on the inventory export supplied by Contoso</a:t>
             </a:r>
           </a:p>
           <a:p>

</xml_diff>

<commit_message>
Fix Word table column widths and slide scorecard header wrapping; add PDF previews
Word tables now fill the page width with set column proportions (written to the
table grid and every cell, which Word and LibreOffice both honour), fixing
squeezed Action/Detail columns. The deck's scorecard columns no longer wrap
their headers. The HTML title is a plain name and the sticky nav respects
phone safe areas. Sample reports are regenerated, with PDF previews.

Co-Authored-By: Claude Opus 5.5 <noreply@anthropic.com>
Claude-Session: https://claude.ai/code/session_01A3HbwoCp6EKz1YzLWTo4jQ
</commit_message>
<xml_diff>
--- a/azure-assessment/sample-reports/contoso-azure-assessment.pptx
+++ b/azure-assessment/sample-reports/contoso-azure-assessment.pptx
@@ -7390,7 +7390,7 @@
         </p:nvGraphicFramePr>
         <p:xfrm>
           <a:off x="6400800" y="1554480"/>
-          <a:ext cx="5303518" cy="2194560"/>
+          <a:ext cx="5303516" cy="2194560"/>
         </p:xfrm>
         <a:graphic>
           <a:graphicData uri="http://schemas.openxmlformats.org/drawingml/2006/table">
@@ -7399,12 +7399,12 @@
                 <a:tableStyleId>{5C22544A-7EE6-4342-B048-85BDC9FD1C3A}</a:tableStyleId>
               </a:tblPr>
               <a:tblGrid>
-                <a:gridCol w="2204060"/>
-                <a:gridCol w="688768"/>
-                <a:gridCol w="757645"/>
-                <a:gridCol w="551015"/>
-                <a:gridCol w="551015"/>
-                <a:gridCol w="551015"/>
+                <a:gridCol w="1854377"/>
+                <a:gridCol w="778838"/>
+                <a:gridCol w="853013"/>
+                <a:gridCol w="630488"/>
+                <a:gridCol w="593400"/>
+                <a:gridCol w="593400"/>
               </a:tblGrid>
               <a:tr h="365760">
                 <a:tc>

</xml_diff>